<commit_message>
Add security controls, deploy runbooks, care platform, GTM materials, and deck updates
Adds platform security modules (JWT verification, approval workflows, audit sinks),
deploy runbooks for all 8 agents, care platform orchestration layer, AWS native
reference architecture, agent handbooks, CI workflow, compliance/security docs
(NIST 800-53, OWASP, threat model), GTM field guides, leave-behind decks, and
refreshes README with streamlined navigation.

Co-Authored-By: Claude Opus 4.6 (1M context) <noreply@anthropic.com>
</commit_message>
<xml_diff>
--- a/decks/HPP-01-Revenue-Cycle-Denial.pptx
+++ b/decks/HPP-01-Revenue-Cycle-Denial.pptx
@@ -1349,7 +1349,7 @@
         <p:spPr>
           <a:xfrm>
             <a:off x="548640" y="640080"/>
-            <a:ext cx="10972800" cy="457200"/>
+            <a:ext cx="8229600" cy="457200"/>
           </a:xfrm>
           <a:prstGeom prst="rect">
             <a:avLst/>
@@ -1382,6 +1382,84 @@
       <p:sp>
         <p:nvSpPr>
           <p:cNvPr id="4" name="Text 2"/>
+          <p:cNvSpPr/>
+          <p:nvPr/>
+        </p:nvSpPr>
+        <p:spPr>
+          <a:xfrm>
+            <a:off x="10561320" y="384048"/>
+            <a:ext cx="1234440" cy="457200"/>
+          </a:xfrm>
+          <a:prstGeom prst="rect">
+            <a:avLst/>
+          </a:prstGeom>
+          <a:noFill/>
+          <a:ln/>
+        </p:spPr>
+        <p:txBody>
+          <a:bodyPr wrap="square" rtlCol="0" anchor="ctr"/>
+          <a:lstStyle/>
+          <a:p>
+            <a:pPr algn="r" indent="0" marL="0">
+              <a:buNone/>
+            </a:pPr>
+            <a:r>
+              <a:rPr lang="en-US" sz="3000" b="1" spc="100" kern="0" dirty="0">
+                <a:solidFill>
+                  <a:srgbClr val="FF9900"/>
+                </a:solidFill>
+                <a:latin typeface="Calibri" pitchFamily="34" charset="0"/>
+                <a:ea typeface="Calibri" pitchFamily="34" charset="-122"/>
+                <a:cs typeface="Calibri" pitchFamily="34" charset="-120"/>
+              </a:rPr>
+              <a:t>aws</a:t>
+            </a:r>
+            <a:endParaRPr lang="en-US" sz="3000" dirty="0"/>
+          </a:p>
+        </p:txBody>
+      </p:sp>
+      <p:sp>
+        <p:nvSpPr>
+          <p:cNvPr id="5" name="Text 3"/>
+          <p:cNvSpPr/>
+          <p:nvPr/>
+        </p:nvSpPr>
+        <p:spPr>
+          <a:xfrm>
+            <a:off x="9966960" y="868680"/>
+            <a:ext cx="1828800" cy="274320"/>
+          </a:xfrm>
+          <a:prstGeom prst="rect">
+            <a:avLst/>
+          </a:prstGeom>
+          <a:noFill/>
+          <a:ln/>
+        </p:spPr>
+        <p:txBody>
+          <a:bodyPr wrap="square" rtlCol="0" anchor="ctr"/>
+          <a:lstStyle/>
+          <a:p>
+            <a:pPr algn="r" indent="0" marL="0">
+              <a:buNone/>
+            </a:pPr>
+            <a:r>
+              <a:rPr lang="en-US" sz="1000" dirty="0">
+                <a:solidFill>
+                  <a:srgbClr val="9DC3E6"/>
+                </a:solidFill>
+                <a:latin typeface="Calibri" pitchFamily="34" charset="0"/>
+                <a:ea typeface="Calibri" pitchFamily="34" charset="-122"/>
+                <a:cs typeface="Calibri" pitchFamily="34" charset="-120"/>
+              </a:rPr>
+              <a:t>Built on AWS</a:t>
+            </a:r>
+            <a:endParaRPr lang="en-US" sz="1000" dirty="0"/>
+          </a:p>
+        </p:txBody>
+      </p:sp>
+      <p:sp>
+        <p:nvSpPr>
+          <p:cNvPr id="6" name="Text 4"/>
           <p:cNvSpPr/>
           <p:nvPr/>
         </p:nvSpPr>
@@ -1420,7 +1498,7 @@
       </p:sp>
       <p:sp>
         <p:nvSpPr>
-          <p:cNvPr id="5" name="Text 3"/>
+          <p:cNvPr id="7" name="Text 5"/>
           <p:cNvSpPr/>
           <p:nvPr/>
         </p:nvSpPr>
@@ -1459,7 +1537,7 @@
       </p:sp>
       <p:sp>
         <p:nvSpPr>
-          <p:cNvPr id="6" name="Text 4"/>
+          <p:cNvPr id="8" name="Text 6"/>
           <p:cNvSpPr/>
           <p:nvPr/>
         </p:nvSpPr>
@@ -1498,7 +1576,7 @@
       </p:sp>
       <p:sp>
         <p:nvSpPr>
-          <p:cNvPr id="7" name="Text 5"/>
+          <p:cNvPr id="9" name="Text 7"/>
           <p:cNvSpPr/>
           <p:nvPr/>
         </p:nvSpPr>
@@ -1610,7 +1688,7 @@
         <p:spPr>
           <a:xfrm>
             <a:off x="548640" y="457200"/>
-            <a:ext cx="10972800" cy="640080"/>
+            <a:ext cx="9144000" cy="640080"/>
           </a:xfrm>
           <a:prstGeom prst="rect">
             <a:avLst/>
@@ -1648,6 +1726,84 @@
         </p:nvSpPr>
         <p:spPr>
           <a:xfrm>
+            <a:off x="10561320" y="384048"/>
+            <a:ext cx="1234440" cy="457200"/>
+          </a:xfrm>
+          <a:prstGeom prst="rect">
+            <a:avLst/>
+          </a:prstGeom>
+          <a:noFill/>
+          <a:ln/>
+        </p:spPr>
+        <p:txBody>
+          <a:bodyPr wrap="square" rtlCol="0" anchor="ctr"/>
+          <a:lstStyle/>
+          <a:p>
+            <a:pPr algn="r" indent="0" marL="0">
+              <a:buNone/>
+            </a:pPr>
+            <a:r>
+              <a:rPr lang="en-US" sz="3000" b="1" spc="100" kern="0" dirty="0">
+                <a:solidFill>
+                  <a:srgbClr val="FF9900"/>
+                </a:solidFill>
+                <a:latin typeface="Calibri" pitchFamily="34" charset="0"/>
+                <a:ea typeface="Calibri" pitchFamily="34" charset="-122"/>
+                <a:cs typeface="Calibri" pitchFamily="34" charset="-120"/>
+              </a:rPr>
+              <a:t>aws</a:t>
+            </a:r>
+            <a:endParaRPr lang="en-US" sz="3000" dirty="0"/>
+          </a:p>
+        </p:txBody>
+      </p:sp>
+      <p:sp>
+        <p:nvSpPr>
+          <p:cNvPr id="5" name="Text 3"/>
+          <p:cNvSpPr/>
+          <p:nvPr/>
+        </p:nvSpPr>
+        <p:spPr>
+          <a:xfrm>
+            <a:off x="9966960" y="868680"/>
+            <a:ext cx="1828800" cy="274320"/>
+          </a:xfrm>
+          <a:prstGeom prst="rect">
+            <a:avLst/>
+          </a:prstGeom>
+          <a:noFill/>
+          <a:ln/>
+        </p:spPr>
+        <p:txBody>
+          <a:bodyPr wrap="square" rtlCol="0" anchor="ctr"/>
+          <a:lstStyle/>
+          <a:p>
+            <a:pPr algn="r" indent="0" marL="0">
+              <a:buNone/>
+            </a:pPr>
+            <a:r>
+              <a:rPr lang="en-US" sz="1000" dirty="0">
+                <a:solidFill>
+                  <a:srgbClr val="9DC3E6"/>
+                </a:solidFill>
+                <a:latin typeface="Calibri" pitchFamily="34" charset="0"/>
+                <a:ea typeface="Calibri" pitchFamily="34" charset="-122"/>
+                <a:cs typeface="Calibri" pitchFamily="34" charset="-120"/>
+              </a:rPr>
+              <a:t>Built on AWS</a:t>
+            </a:r>
+            <a:endParaRPr lang="en-US" sz="1000" dirty="0"/>
+          </a:p>
+        </p:txBody>
+      </p:sp>
+      <p:sp>
+        <p:nvSpPr>
+          <p:cNvPr id="6" name="Text 4"/>
+          <p:cNvSpPr/>
+          <p:nvPr/>
+        </p:nvSpPr>
+        <p:spPr>
+          <a:xfrm>
             <a:off x="548640" y="1325880"/>
             <a:ext cx="11064240" cy="822960"/>
           </a:xfrm>
@@ -1681,7 +1837,7 @@
       </p:sp>
       <p:sp>
         <p:nvSpPr>
-          <p:cNvPr id="5" name="Shape 3"/>
+          <p:cNvPr id="7" name="Shape 5"/>
           <p:cNvSpPr/>
           <p:nvPr/>
         </p:nvSpPr>
@@ -1703,7 +1859,7 @@
       </p:sp>
       <p:sp>
         <p:nvSpPr>
-          <p:cNvPr id="6" name="Text 4"/>
+          <p:cNvPr id="8" name="Text 6"/>
           <p:cNvSpPr/>
           <p:nvPr/>
         </p:nvSpPr>
@@ -1742,7 +1898,7 @@
       </p:sp>
       <p:sp>
         <p:nvSpPr>
-          <p:cNvPr id="7" name="Text 5"/>
+          <p:cNvPr id="9" name="Text 7"/>
           <p:cNvSpPr/>
           <p:nvPr/>
         </p:nvSpPr>
@@ -1781,7 +1937,7 @@
       </p:sp>
       <p:sp>
         <p:nvSpPr>
-          <p:cNvPr id="8" name="Shape 6"/>
+          <p:cNvPr id="10" name="Shape 8"/>
           <p:cNvSpPr/>
           <p:nvPr/>
         </p:nvSpPr>
@@ -1803,7 +1959,7 @@
       </p:sp>
       <p:sp>
         <p:nvSpPr>
-          <p:cNvPr id="9" name="Text 7"/>
+          <p:cNvPr id="11" name="Text 9"/>
           <p:cNvSpPr/>
           <p:nvPr/>
         </p:nvSpPr>
@@ -1842,7 +1998,7 @@
       </p:sp>
       <p:sp>
         <p:nvSpPr>
-          <p:cNvPr id="10" name="Text 8"/>
+          <p:cNvPr id="12" name="Text 10"/>
           <p:cNvSpPr/>
           <p:nvPr/>
         </p:nvSpPr>
@@ -1881,7 +2037,7 @@
       </p:sp>
       <p:sp>
         <p:nvSpPr>
-          <p:cNvPr id="11" name="Shape 9"/>
+          <p:cNvPr id="13" name="Shape 11"/>
           <p:cNvSpPr/>
           <p:nvPr/>
         </p:nvSpPr>
@@ -1903,7 +2059,7 @@
       </p:sp>
       <p:sp>
         <p:nvSpPr>
-          <p:cNvPr id="12" name="Text 10"/>
+          <p:cNvPr id="14" name="Text 12"/>
           <p:cNvSpPr/>
           <p:nvPr/>
         </p:nvSpPr>
@@ -1942,7 +2098,7 @@
       </p:sp>
       <p:sp>
         <p:nvSpPr>
-          <p:cNvPr id="13" name="Text 11"/>
+          <p:cNvPr id="15" name="Text 13"/>
           <p:cNvSpPr/>
           <p:nvPr/>
         </p:nvSpPr>
@@ -1981,7 +2137,7 @@
       </p:sp>
       <p:sp>
         <p:nvSpPr>
-          <p:cNvPr id="14" name="Text 12"/>
+          <p:cNvPr id="16" name="Text 14"/>
           <p:cNvSpPr/>
           <p:nvPr/>
         </p:nvSpPr>
@@ -2020,7 +2176,7 @@
       </p:sp>
       <p:sp>
         <p:nvSpPr>
-          <p:cNvPr id="15" name="Text 13"/>
+          <p:cNvPr id="17" name="Text 15"/>
           <p:cNvSpPr/>
           <p:nvPr/>
         </p:nvSpPr>
@@ -4450,7 +4606,7 @@
         <p:spPr>
           <a:xfrm>
             <a:off x="548640" y="457200"/>
-            <a:ext cx="10972800" cy="640080"/>
+            <a:ext cx="9144000" cy="640080"/>
           </a:xfrm>
           <a:prstGeom prst="rect">
             <a:avLst/>
@@ -4482,7 +4638,85 @@
       </p:sp>
       <p:sp>
         <p:nvSpPr>
-          <p:cNvPr id="4" name="Shape 2"/>
+          <p:cNvPr id="4" name="Text 2"/>
+          <p:cNvSpPr/>
+          <p:nvPr/>
+        </p:nvSpPr>
+        <p:spPr>
+          <a:xfrm>
+            <a:off x="10561320" y="384048"/>
+            <a:ext cx="1234440" cy="457200"/>
+          </a:xfrm>
+          <a:prstGeom prst="rect">
+            <a:avLst/>
+          </a:prstGeom>
+          <a:noFill/>
+          <a:ln/>
+        </p:spPr>
+        <p:txBody>
+          <a:bodyPr wrap="square" rtlCol="0" anchor="ctr"/>
+          <a:lstStyle/>
+          <a:p>
+            <a:pPr algn="r" indent="0" marL="0">
+              <a:buNone/>
+            </a:pPr>
+            <a:r>
+              <a:rPr lang="en-US" sz="3000" b="1" spc="100" kern="0" dirty="0">
+                <a:solidFill>
+                  <a:srgbClr val="FF9900"/>
+                </a:solidFill>
+                <a:latin typeface="Calibri" pitchFamily="34" charset="0"/>
+                <a:ea typeface="Calibri" pitchFamily="34" charset="-122"/>
+                <a:cs typeface="Calibri" pitchFamily="34" charset="-120"/>
+              </a:rPr>
+              <a:t>aws</a:t>
+            </a:r>
+            <a:endParaRPr lang="en-US" sz="3000" dirty="0"/>
+          </a:p>
+        </p:txBody>
+      </p:sp>
+      <p:sp>
+        <p:nvSpPr>
+          <p:cNvPr id="5" name="Text 3"/>
+          <p:cNvSpPr/>
+          <p:nvPr/>
+        </p:nvSpPr>
+        <p:spPr>
+          <a:xfrm>
+            <a:off x="9966960" y="868680"/>
+            <a:ext cx="1828800" cy="274320"/>
+          </a:xfrm>
+          <a:prstGeom prst="rect">
+            <a:avLst/>
+          </a:prstGeom>
+          <a:noFill/>
+          <a:ln/>
+        </p:spPr>
+        <p:txBody>
+          <a:bodyPr wrap="square" rtlCol="0" anchor="ctr"/>
+          <a:lstStyle/>
+          <a:p>
+            <a:pPr algn="r" indent="0" marL="0">
+              <a:buNone/>
+            </a:pPr>
+            <a:r>
+              <a:rPr lang="en-US" sz="1000" dirty="0">
+                <a:solidFill>
+                  <a:srgbClr val="9DC3E6"/>
+                </a:solidFill>
+                <a:latin typeface="Calibri" pitchFamily="34" charset="0"/>
+                <a:ea typeface="Calibri" pitchFamily="34" charset="-122"/>
+                <a:cs typeface="Calibri" pitchFamily="34" charset="-120"/>
+              </a:rPr>
+              <a:t>Built on AWS</a:t>
+            </a:r>
+            <a:endParaRPr lang="en-US" sz="1000" dirty="0"/>
+          </a:p>
+        </p:txBody>
+      </p:sp>
+      <p:sp>
+        <p:nvSpPr>
+          <p:cNvPr id="6" name="Shape 4"/>
           <p:cNvSpPr/>
           <p:nvPr/>
         </p:nvSpPr>
@@ -4504,7 +4738,7 @@
       </p:sp>
       <p:sp>
         <p:nvSpPr>
-          <p:cNvPr id="5" name="Text 3"/>
+          <p:cNvPr id="7" name="Text 5"/>
           <p:cNvSpPr/>
           <p:nvPr/>
         </p:nvSpPr>
@@ -4557,7 +4791,7 @@
       </p:sp>
       <p:sp>
         <p:nvSpPr>
-          <p:cNvPr id="6" name="Text 4"/>
+          <p:cNvPr id="8" name="Text 6"/>
           <p:cNvSpPr/>
           <p:nvPr/>
         </p:nvSpPr>
@@ -4663,7 +4897,7 @@
       </p:sp>
       <p:sp>
         <p:nvSpPr>
-          <p:cNvPr id="7" name="Shape 5"/>
+          <p:cNvPr id="9" name="Shape 7"/>
           <p:cNvSpPr/>
           <p:nvPr/>
         </p:nvSpPr>
@@ -4685,7 +4919,7 @@
       </p:sp>
       <p:sp>
         <p:nvSpPr>
-          <p:cNvPr id="8" name="Text 6"/>
+          <p:cNvPr id="10" name="Text 8"/>
           <p:cNvSpPr/>
           <p:nvPr/>
         </p:nvSpPr>
@@ -4724,7 +4958,7 @@
       </p:sp>
       <p:sp>
         <p:nvSpPr>
-          <p:cNvPr id="9" name="Text 7"/>
+          <p:cNvPr id="11" name="Text 9"/>
           <p:cNvSpPr/>
           <p:nvPr/>
         </p:nvSpPr>
@@ -4830,7 +5064,7 @@
       </p:sp>
       <p:sp>
         <p:nvSpPr>
-          <p:cNvPr id="10" name="Text 8"/>
+          <p:cNvPr id="12" name="Text 10"/>
           <p:cNvSpPr/>
           <p:nvPr/>
         </p:nvSpPr>
@@ -4869,7 +5103,7 @@
       </p:sp>
       <p:sp>
         <p:nvSpPr>
-          <p:cNvPr id="11" name="Text 9"/>
+          <p:cNvPr id="13" name="Text 11"/>
           <p:cNvSpPr/>
           <p:nvPr/>
         </p:nvSpPr>

</xml_diff>

<commit_message>
Add capability maturity matrix, architecture diagrams, TCO estimates, and acceptance evidence
185 tests green (up from 144). Adds README capability maturity matrix and
validation update, PHI data-flow and MCP gateway auth-flow diagrams,
numeric pilot/production TCO estimates, sanitized clean-account acceptance
report, and PrivateLink language refinement across docs/IaC. Removes
completed remediation plans and IMPROVEMENTS-OVER-SLG. Fixes README
truncation from prior edit session.

Co-Authored-By: Claude Opus 4.6 (1M context) <noreply@anthropic.com>
</commit_message>
<xml_diff>
--- a/decks/HPP-01-Revenue-Cycle-Denial.pptx
+++ b/decks/HPP-01-Revenue-Cycle-Denial.pptx
@@ -5173,28 +5173,28 @@
         <a:sysClr val="window" lastClr="FFFFFF"/>
       </a:lt1>
       <a:dk2>
-        <a:srgbClr val="44546A"/>
+        <a:srgbClr val="232F3E"/>
       </a:dk2>
       <a:lt2>
         <a:srgbClr val="E7E6E6"/>
       </a:lt2>
       <a:accent1>
-        <a:srgbClr val="4472C4"/>
+        <a:srgbClr val="FF9900"/>
       </a:accent1>
       <a:accent2>
-        <a:srgbClr val="ED7D31"/>
+        <a:srgbClr val="232F3E"/>
       </a:accent2>
       <a:accent3>
-        <a:srgbClr val="A5A5A5"/>
+        <a:srgbClr val="01A88D"/>
       </a:accent3>
       <a:accent4>
-        <a:srgbClr val="FFC000"/>
+        <a:srgbClr val="8C4FFF"/>
       </a:accent4>
       <a:accent5>
-        <a:srgbClr val="5B9BD5"/>
+        <a:srgbClr val="DD344C"/>
       </a:accent5>
       <a:accent6>
-        <a:srgbClr val="70AD47"/>
+        <a:srgbClr val="ED7100"/>
       </a:accent6>
       <a:hlink>
         <a:srgbClr val="0563C1"/>
@@ -5205,7 +5205,7 @@
     </a:clrScheme>
     <a:fontScheme name="Office">
       <a:majorFont>
-        <a:latin typeface="Calibri Light" panose="020F0302020204030204"/>
+        <a:latin typeface="Amazon Ember" panose="020F0302020204030204"/>
         <a:ea typeface=""/>
         <a:cs typeface=""/>
         <a:font script="Jpan" typeface="游ゴシック Light"/>
@@ -5257,7 +5257,7 @@
         <a:font script="Tfng" typeface="Ebrima"/>
       </a:majorFont>
       <a:minorFont>
-        <a:latin typeface="Calibri" panose="020F0502020204030204"/>
+        <a:latin typeface="Amazon Ember" panose="020F0502020204030204"/>
         <a:ea typeface=""/>
         <a:cs typeface=""/>
         <a:font script="Jpan" typeface="游ゴシック"/>

</xml_diff>

<commit_message>
Add Comprehend Medical PHI engine, IdP federation addon, assurance packet, and AgentCore honesty labels
New features:
- Amazon Comprehend Medical DetectPHI as opt-in ML NER engine (PHI_ENGINE=comprehend_medical),
  fail-closed, belt-and-suspenders with the deterministic Safe-Harbor pass (13 tests green)
- IdP federation CloudFormation addon (SAML/OIDC for Okta/Entra) + runbook
- Auditor/GRC assurance cover-sheet packet (assurance/README.md)
- Golden-path template: PhiEngine parameter with gated comprehendmedical:DetectPHI IAM

Honesty corrections:
- AgentCore gateway marked EXPERIMENTAL/incomplete (missing per-tool ToolSchema)
  across all docs, IaC, and architecture references
- Portable API Gateway+Cognito JWT pattern documented as the supported default

Co-Authored-By: Claude Opus 4.6 (1M context) <noreply@anthropic.com>
</commit_message>
<xml_diff>
--- a/decks/HPP-01-Revenue-Cycle-Denial.pptx
+++ b/decks/HPP-01-Revenue-Cycle-Denial.pptx
@@ -11,6 +11,7 @@
     <p:sldId id="259" r:id="rId5"/>
     <p:sldId id="260" r:id="rId6"/>
     <p:sldId id="261" r:id="rId7"/>
+    <p:sldId id="262" r:id="rId13"/>
   </p:sldIdLst>
   <p:notesMasterIdLst>
     <p:notesMasterId r:id="rId8"/>
@@ -1627,6 +1628,40 @@
           </a:p>
         </p:txBody>
       </p:sp>
+      <p:sp>
+        <p:nvSpPr>
+          <p:cNvPr id="10" name="TextBox 9"/>
+          <p:cNvSpPr txBox="1"/>
+          <p:nvPr/>
+        </p:nvSpPr>
+        <p:spPr>
+          <a:xfrm>
+            <a:off x="365760" y="6291072"/>
+            <a:ext cx="11460175" cy="457200"/>
+          </a:xfrm>
+          <a:prstGeom prst="rect">
+            <a:avLst/>
+          </a:prstGeom>
+          <a:noFill/>
+        </p:spPr>
+        <p:txBody>
+          <a:bodyPr wrap="square" tIns="0" bIns="0">
+            <a:spAutoFit/>
+          </a:bodyPr>
+          <a:lstStyle/>
+          <a:p>
+            <a:pPr algn="l"/>
+            <a:r>
+              <a:rPr sz="800" i="1">
+                <a:solidFill>
+                  <a:srgbClr val="879296"/>
+                </a:solidFill>
+              </a:rPr>
+              <a:t>Reference accelerator — not an AWS service, not AWS-supported software, not a compliance certification, and not production-ready for regulated data without customer-specific engineering, testing, authorization, and operational ownership.</a:t>
+            </a:r>
+          </a:p>
+        </p:txBody>
+      </p:sp>
     </p:spTree>
   </p:cSld>
   <p:clrMapOvr>
@@ -5151,6 +5186,198 @@
               <a:t>   ·   Health Providers &amp; Plans   ·   Governed AI on AWS   ·   HPP-01</a:t>
             </a:r>
             <a:endParaRPr lang="en-US" sz="1100" dirty="0"/>
+          </a:p>
+        </p:txBody>
+      </p:sp>
+    </p:spTree>
+  </p:cSld>
+  <p:clrMapOvr>
+    <a:masterClrMapping/>
+  </p:clrMapOvr>
+</p:sld>
+</file>
+
+<file path=ppt/slides/slide7.xml><?xml version="1.0" encoding="utf-8"?>
+<p:sld xmlns:a="http://schemas.openxmlformats.org/drawingml/2006/main" xmlns:p="http://schemas.openxmlformats.org/presentationml/2006/main" xmlns:r="http://schemas.openxmlformats.org/officeDocument/2006/relationships">
+  <p:cSld>
+    <p:spTree>
+      <p:nvGrpSpPr>
+        <p:cNvPr id="1" name=""/>
+        <p:cNvGrpSpPr/>
+        <p:nvPr/>
+      </p:nvGrpSpPr>
+      <p:grpSpPr/>
+      <p:sp>
+        <p:nvSpPr>
+          <p:cNvPr id="2" name="Rectangle 1"/>
+          <p:cNvSpPr/>
+          <p:nvPr/>
+        </p:nvSpPr>
+        <p:spPr>
+          <a:xfrm>
+            <a:off x="0" y="0"/>
+            <a:ext cx="12191695" cy="6858000"/>
+          </a:xfrm>
+          <a:prstGeom prst="rect">
+            <a:avLst/>
+          </a:prstGeom>
+          <a:solidFill>
+            <a:srgbClr val="232F3E"/>
+          </a:solidFill>
+          <a:ln>
+            <a:noFill/>
+          </a:ln>
+          <a:effectLst/>
+        </p:spPr>
+        <p:style>
+          <a:lnRef idx="1">
+            <a:schemeClr val="accent1"/>
+          </a:lnRef>
+          <a:fillRef idx="3">
+            <a:schemeClr val="accent1"/>
+          </a:fillRef>
+          <a:effectRef idx="2">
+            <a:schemeClr val="accent1"/>
+          </a:effectRef>
+          <a:fontRef idx="minor">
+            <a:schemeClr val="lt1"/>
+          </a:fontRef>
+        </p:style>
+        <p:txBody>
+          <a:bodyPr rtlCol="0" anchor="ctr"/>
+          <a:lstStyle/>
+          <a:p>
+            <a:pPr algn="ctr"/>
+          </a:p>
+        </p:txBody>
+      </p:sp>
+      <p:sp>
+        <p:nvSpPr>
+          <p:cNvPr id="3" name="Rectangle 2"/>
+          <p:cNvSpPr/>
+          <p:nvPr/>
+        </p:nvSpPr>
+        <p:spPr>
+          <a:xfrm>
+            <a:off x="822960" y="1051560"/>
+            <a:ext cx="2011680" cy="82296"/>
+          </a:xfrm>
+          <a:prstGeom prst="rect">
+            <a:avLst/>
+          </a:prstGeom>
+          <a:solidFill>
+            <a:srgbClr val="FF9900"/>
+          </a:solidFill>
+          <a:ln>
+            <a:noFill/>
+          </a:ln>
+          <a:effectLst/>
+        </p:spPr>
+        <p:style>
+          <a:lnRef idx="1">
+            <a:schemeClr val="accent1"/>
+          </a:lnRef>
+          <a:fillRef idx="3">
+            <a:schemeClr val="accent1"/>
+          </a:fillRef>
+          <a:effectRef idx="2">
+            <a:schemeClr val="accent1"/>
+          </a:effectRef>
+          <a:fontRef idx="minor">
+            <a:schemeClr val="lt1"/>
+          </a:fontRef>
+        </p:style>
+        <p:txBody>
+          <a:bodyPr rtlCol="0" anchor="ctr"/>
+          <a:lstStyle/>
+          <a:p>
+            <a:pPr algn="ctr"/>
+          </a:p>
+        </p:txBody>
+      </p:sp>
+      <p:sp>
+        <p:nvSpPr>
+          <p:cNvPr id="4" name="TextBox 3"/>
+          <p:cNvSpPr txBox="1"/>
+          <p:nvPr/>
+        </p:nvSpPr>
+        <p:spPr>
+          <a:xfrm>
+            <a:off x="822960" y="1234440"/>
+            <a:ext cx="10545775" cy="914400"/>
+          </a:xfrm>
+          <a:prstGeom prst="rect">
+            <a:avLst/>
+          </a:prstGeom>
+          <a:noFill/>
+        </p:spPr>
+        <p:txBody>
+          <a:bodyPr wrap="square">
+            <a:spAutoFit/>
+          </a:bodyPr>
+          <a:lstStyle/>
+          <a:p>
+            <a:r>
+              <a:rPr sz="3400" b="1">
+                <a:solidFill>
+                  <a:srgbClr val="FFFFFF"/>
+                </a:solidFill>
+              </a:rPr>
+              <a:t>Disclaimer &amp; Shared Responsibility</a:t>
+            </a:r>
+          </a:p>
+        </p:txBody>
+      </p:sp>
+      <p:sp>
+        <p:nvSpPr>
+          <p:cNvPr id="5" name="TextBox 4"/>
+          <p:cNvSpPr txBox="1"/>
+          <p:nvPr/>
+        </p:nvSpPr>
+        <p:spPr>
+          <a:xfrm>
+            <a:off x="822960" y="2468880"/>
+            <a:ext cx="10545775" cy="3108960"/>
+          </a:xfrm>
+          <a:prstGeom prst="rect">
+            <a:avLst/>
+          </a:prstGeom>
+          <a:noFill/>
+        </p:spPr>
+        <p:txBody>
+          <a:bodyPr wrap="square">
+            <a:spAutoFit/>
+          </a:bodyPr>
+          <a:lstStyle/>
+          <a:p>
+            <a:pPr>
+              <a:spcAft>
+                <a:spcPts val="1200"/>
+              </a:spcAft>
+            </a:pPr>
+            <a:r>
+              <a:rPr sz="1600">
+                <a:solidFill>
+                  <a:srgbClr val="D5DBDB"/>
+                </a:solidFill>
+              </a:rPr>
+              <a:t>Reference accelerator — not an AWS service, not AWS-supported software, not a compliance certification, and not production-ready for regulated data without customer-specific engineering, testing, authorization, and operational ownership.</a:t>
+            </a:r>
+          </a:p>
+          <a:p>
+            <a:pPr>
+              <a:spcAft>
+                <a:spcPts val="1200"/>
+              </a:spcAft>
+            </a:pPr>
+            <a:r>
+              <a:rPr sz="1600">
+                <a:solidFill>
+                  <a:srgbClr val="D5DBDB"/>
+                </a:solidFill>
+              </a:rPr>
+              <a:t>Built on AWS; not affiliated with or endorsed by Amazon Web Services.</a:t>
+            </a:r>
           </a:p>
         </p:txBody>
       </p:sp>

</xml_diff>